<commit_message>
Add cv site generated using Klar AI based on my CV
</commit_message>
<xml_diff>
--- a/CV/RBF.pptx
+++ b/CV/RBF.pptx
@@ -242,7 +242,7 @@
             <a:fld id="{86C988DC-9DE3-4390-97AB-D61B85DACE57}" type="datetimeFigureOut">
               <a:rPr lang="pt-PT" sz="900" smtClean="0"/>
               <a:pPr/>
-              <a:t>27/11/2025</a:t>
+              <a:t>12/12/2025</a:t>
             </a:fld>
             <a:endParaRPr lang="pt-PT" sz="900"/>
           </a:p>
@@ -421,7 +421,7 @@
             <a:fld id="{0835B8F7-DAC4-4931-8AED-4356A8B2FD64}" type="datetimeFigureOut">
               <a:rPr lang="pt-BR" smtClean="0"/>
               <a:pPr/>
-              <a:t>27/11/2025</a:t>
+              <a:t>12/12/2025</a:t>
             </a:fld>
             <a:endParaRPr lang="pt-BR"/>
           </a:p>
@@ -1678,7 +1678,7 @@
         <p:spPr>
           <a:xfrm>
             <a:off x="4141430" y="5925988"/>
-            <a:ext cx="2746721" cy="781876"/>
+            <a:ext cx="2746721" cy="932012"/>
           </a:xfrm>
           <a:prstGeom prst="rect">
             <a:avLst/>
@@ -1843,7 +1843,7 @@
                 <a:latin typeface="Ubuntu" panose="020B0504030602030204" pitchFamily="34" charset="0"/>
                 <a:ea typeface="Verdana"/>
               </a:rPr>
-              <a:t> using Ve</a:t>
+              <a:t> (Vector Certified Embedded Associate)</a:t>
             </a:r>
           </a:p>
           <a:p>
@@ -5492,6 +5492,15 @@
 </file>
 
 <file path=customXml/item2.xml><?xml version="1.0" encoding="utf-8"?>
+<?mso-contentType ?>
+<FormTemplates xmlns="http://schemas.microsoft.com/sharepoint/v3/contenttype/forms">
+  <Display>DocumentLibraryForm</Display>
+  <Edit>DocumentLibraryForm</Edit>
+  <New>DocumentLibraryForm</New>
+</FormTemplates>
+</file>
+
+<file path=customXml/item3.xml><?xml version="1.0" encoding="utf-8"?>
 <ct:contentTypeSchema xmlns:ct="http://schemas.microsoft.com/office/2006/metadata/contentType" xmlns:ma="http://schemas.microsoft.com/office/2006/metadata/properties/metaAttributes" ct:_="" ma:_="" ma:contentTypeName="Document" ma:contentTypeID="0x01010028379B9164345D4B9FEA71B5C6DA0501" ma:contentTypeVersion="12" ma:contentTypeDescription="Create a new document." ma:contentTypeScope="" ma:versionID="25a509c6a27b952c0dae28f88f47ece3">
   <xsd:schema xmlns:xsd="http://www.w3.org/2001/XMLSchema" xmlns:xs="http://www.w3.org/2001/XMLSchema" xmlns:p="http://schemas.microsoft.com/office/2006/metadata/properties" xmlns:ns2="cddac4ca-1f9a-48ec-a052-f880be6be43c" xmlns:ns3="70ba0579-5a3d-4697-904b-f432645238e6" targetNamespace="http://schemas.microsoft.com/office/2006/metadata/properties" ma:root="true" ma:fieldsID="3585157dcfd28b9b0093472ca559abd9" ns2:_="" ns3:_="">
     <xsd:import namespace="cddac4ca-1f9a-48ec-a052-f880be6be43c"/>
@@ -5708,15 +5717,6 @@
 </ct:contentTypeSchema>
 </file>
 
-<file path=customXml/item3.xml><?xml version="1.0" encoding="utf-8"?>
-<?mso-contentType ?>
-<FormTemplates xmlns="http://schemas.microsoft.com/sharepoint/v3/contenttype/forms">
-  <Display>DocumentLibraryForm</Display>
-  <Edit>DocumentLibraryForm</Edit>
-  <New>DocumentLibraryForm</New>
-</FormTemplates>
-</file>
-
 <file path=customXml/itemProps1.xml><?xml version="1.0" encoding="utf-8"?>
 <ds:datastoreItem xmlns:ds="http://schemas.openxmlformats.org/officeDocument/2006/customXml" ds:itemID="{8765F6DA-EDFD-4C3F-B2EB-EDE359E124E2}">
   <ds:schemaRefs>
@@ -5735,6 +5735,14 @@
 </file>
 
 <file path=customXml/itemProps2.xml><?xml version="1.0" encoding="utf-8"?>
+<ds:datastoreItem xmlns:ds="http://schemas.openxmlformats.org/officeDocument/2006/customXml" ds:itemID="{93B09ECE-D1C0-42A5-B69E-8C88764DB9F3}">
+  <ds:schemaRefs>
+    <ds:schemaRef ds:uri="http://schemas.microsoft.com/sharepoint/v3/contenttype/forms"/>
+  </ds:schemaRefs>
+</ds:datastoreItem>
+</file>
+
+<file path=customXml/itemProps3.xml><?xml version="1.0" encoding="utf-8"?>
 <ds:datastoreItem xmlns:ds="http://schemas.openxmlformats.org/officeDocument/2006/customXml" ds:itemID="{DB6846BF-D536-4981-BB4E-DAFD3540F1ED}">
   <ds:schemaRefs>
     <ds:schemaRef ds:uri="http://schemas.microsoft.com/office/2006/metadata/contentType"/>
@@ -5753,14 +5761,6 @@
 </ds:datastoreItem>
 </file>
 
-<file path=customXml/itemProps3.xml><?xml version="1.0" encoding="utf-8"?>
-<ds:datastoreItem xmlns:ds="http://schemas.openxmlformats.org/officeDocument/2006/customXml" ds:itemID="{93B09ECE-D1C0-42A5-B69E-8C88764DB9F3}">
-  <ds:schemaRefs>
-    <ds:schemaRef ds:uri="http://schemas.microsoft.com/sharepoint/v3/contenttype/forms"/>
-  </ds:schemaRefs>
-</ds:datastoreItem>
-</file>
-
 <file path=docMetadata/LabelInfo.xml><?xml version="1.0" encoding="utf-8"?>
 <clbl:labelList xmlns:clbl="http://schemas.microsoft.com/office/2020/mipLabelMetadata">
   <clbl:label id="{76a2ae5a-9f00-4f6b-95ed-5d33d77c4d61}" enabled="0" method="" siteId="{76a2ae5a-9f00-4f6b-95ed-5d33d77c4d61}" removed="1"/>

</xml_diff>